<commit_message>
update final espqro eu
</commit_message>
<xml_diff>
--- a/YourMedia – Base de dados de Críticas DE.pptx
+++ b/YourMedia – Base de dados de Críticas DE.pptx
@@ -13,8 +13,9 @@
     <p:sldId id="261" r:id="rId7"/>
     <p:sldId id="264" r:id="rId8"/>
     <p:sldId id="265" r:id="rId9"/>
-    <p:sldId id="266" r:id="rId10"/>
-    <p:sldId id="262" r:id="rId11"/>
+    <p:sldId id="267" r:id="rId10"/>
+    <p:sldId id="266" r:id="rId11"/>
+    <p:sldId id="262" r:id="rId12"/>
   </p:sldIdLst>
   <p:sldSz cx="12192000" cy="6858000"/>
   <p:notesSz cx="6858000" cy="9144000"/>
@@ -312,7 +313,7 @@
           <a:p>
             <a:fld id="{FDF12D24-041E-47B5-A04A-AD40504B93F3}" type="datetimeFigureOut">
               <a:rPr lang="pt-PT" smtClean="0"/>
-              <a:t>21/06/2022</a:t>
+              <a:t>22/06/2022</a:t>
             </a:fld>
             <a:endParaRPr lang="pt-PT"/>
           </a:p>
@@ -748,7 +749,7 @@
           <a:p>
             <a:fld id="{FDF12D24-041E-47B5-A04A-AD40504B93F3}" type="datetimeFigureOut">
               <a:rPr lang="pt-PT" smtClean="0"/>
-              <a:t>21/06/2022</a:t>
+              <a:t>22/06/2022</a:t>
             </a:fld>
             <a:endParaRPr lang="pt-PT"/>
           </a:p>
@@ -998,7 +999,7 @@
           <a:p>
             <a:fld id="{FDF12D24-041E-47B5-A04A-AD40504B93F3}" type="datetimeFigureOut">
               <a:rPr lang="pt-PT" smtClean="0"/>
-              <a:t>21/06/2022</a:t>
+              <a:t>22/06/2022</a:t>
             </a:fld>
             <a:endParaRPr lang="pt-PT"/>
           </a:p>
@@ -1306,7 +1307,7 @@
           <a:p>
             <a:fld id="{FDF12D24-041E-47B5-A04A-AD40504B93F3}" type="datetimeFigureOut">
               <a:rPr lang="pt-PT" smtClean="0"/>
-              <a:t>21/06/2022</a:t>
+              <a:t>22/06/2022</a:t>
             </a:fld>
             <a:endParaRPr lang="pt-PT"/>
           </a:p>
@@ -1624,7 +1625,7 @@
           <a:p>
             <a:fld id="{FDF12D24-041E-47B5-A04A-AD40504B93F3}" type="datetimeFigureOut">
               <a:rPr lang="pt-PT" smtClean="0"/>
-              <a:t>21/06/2022</a:t>
+              <a:t>22/06/2022</a:t>
             </a:fld>
             <a:endParaRPr lang="pt-PT"/>
           </a:p>
@@ -1926,7 +1927,7 @@
           <a:p>
             <a:fld id="{FDF12D24-041E-47B5-A04A-AD40504B93F3}" type="datetimeFigureOut">
               <a:rPr lang="pt-PT" smtClean="0"/>
-              <a:t>21/06/2022</a:t>
+              <a:t>22/06/2022</a:t>
             </a:fld>
             <a:endParaRPr lang="pt-PT"/>
           </a:p>
@@ -2293,7 +2294,7 @@
           <a:p>
             <a:fld id="{FDF12D24-041E-47B5-A04A-AD40504B93F3}" type="datetimeFigureOut">
               <a:rPr lang="pt-PT" smtClean="0"/>
-              <a:t>21/06/2022</a:t>
+              <a:t>22/06/2022</a:t>
             </a:fld>
             <a:endParaRPr lang="pt-PT"/>
           </a:p>
@@ -2467,7 +2468,7 @@
           <a:p>
             <a:fld id="{FDF12D24-041E-47B5-A04A-AD40504B93F3}" type="datetimeFigureOut">
               <a:rPr lang="pt-PT" smtClean="0"/>
-              <a:t>21/06/2022</a:t>
+              <a:t>22/06/2022</a:t>
             </a:fld>
             <a:endParaRPr lang="pt-PT"/>
           </a:p>
@@ -2647,7 +2648,7 @@
           <a:p>
             <a:fld id="{FDF12D24-041E-47B5-A04A-AD40504B93F3}" type="datetimeFigureOut">
               <a:rPr lang="pt-PT" smtClean="0"/>
-              <a:t>21/06/2022</a:t>
+              <a:t>22/06/2022</a:t>
             </a:fld>
             <a:endParaRPr lang="pt-PT"/>
           </a:p>
@@ -2817,7 +2818,7 @@
           <a:p>
             <a:fld id="{FDF12D24-041E-47B5-A04A-AD40504B93F3}" type="datetimeFigureOut">
               <a:rPr lang="pt-PT" smtClean="0"/>
-              <a:t>21/06/2022</a:t>
+              <a:t>22/06/2022</a:t>
             </a:fld>
             <a:endParaRPr lang="pt-PT"/>
           </a:p>
@@ -3067,7 +3068,7 @@
           <a:p>
             <a:fld id="{FDF12D24-041E-47B5-A04A-AD40504B93F3}" type="datetimeFigureOut">
               <a:rPr lang="pt-PT" smtClean="0"/>
-              <a:t>21/06/2022</a:t>
+              <a:t>22/06/2022</a:t>
             </a:fld>
             <a:endParaRPr lang="pt-PT"/>
           </a:p>
@@ -3303,7 +3304,7 @@
           <a:p>
             <a:fld id="{FDF12D24-041E-47B5-A04A-AD40504B93F3}" type="datetimeFigureOut">
               <a:rPr lang="pt-PT" smtClean="0"/>
-              <a:t>21/06/2022</a:t>
+              <a:t>22/06/2022</a:t>
             </a:fld>
             <a:endParaRPr lang="pt-PT"/>
           </a:p>
@@ -3685,7 +3686,7 @@
           <a:p>
             <a:fld id="{FDF12D24-041E-47B5-A04A-AD40504B93F3}" type="datetimeFigureOut">
               <a:rPr lang="pt-PT" smtClean="0"/>
-              <a:t>21/06/2022</a:t>
+              <a:t>22/06/2022</a:t>
             </a:fld>
             <a:endParaRPr lang="pt-PT"/>
           </a:p>
@@ -3803,7 +3804,7 @@
           <a:p>
             <a:fld id="{FDF12D24-041E-47B5-A04A-AD40504B93F3}" type="datetimeFigureOut">
               <a:rPr lang="pt-PT" smtClean="0"/>
-              <a:t>21/06/2022</a:t>
+              <a:t>22/06/2022</a:t>
             </a:fld>
             <a:endParaRPr lang="pt-PT"/>
           </a:p>
@@ -3898,7 +3899,7 @@
           <a:p>
             <a:fld id="{FDF12D24-041E-47B5-A04A-AD40504B93F3}" type="datetimeFigureOut">
               <a:rPr lang="pt-PT" smtClean="0"/>
-              <a:t>21/06/2022</a:t>
+              <a:t>22/06/2022</a:t>
             </a:fld>
             <a:endParaRPr lang="pt-PT"/>
           </a:p>
@@ -4153,7 +4154,7 @@
           <a:p>
             <a:fld id="{FDF12D24-041E-47B5-A04A-AD40504B93F3}" type="datetimeFigureOut">
               <a:rPr lang="pt-PT" smtClean="0"/>
-              <a:t>21/06/2022</a:t>
+              <a:t>22/06/2022</a:t>
             </a:fld>
             <a:endParaRPr lang="pt-PT"/>
           </a:p>
@@ -4436,7 +4437,7 @@
           <a:p>
             <a:fld id="{FDF12D24-041E-47B5-A04A-AD40504B93F3}" type="datetimeFigureOut">
               <a:rPr lang="pt-PT" smtClean="0"/>
-              <a:t>21/06/2022</a:t>
+              <a:t>22/06/2022</a:t>
             </a:fld>
             <a:endParaRPr lang="pt-PT"/>
           </a:p>
@@ -4842,7 +4843,7 @@
           <a:p>
             <a:fld id="{FDF12D24-041E-47B5-A04A-AD40504B93F3}" type="datetimeFigureOut">
               <a:rPr lang="pt-PT" smtClean="0"/>
-              <a:t>21/06/2022</a:t>
+              <a:t>22/06/2022</a:t>
             </a:fld>
             <a:endParaRPr lang="pt-PT"/>
           </a:p>
@@ -5491,6 +5492,124 @@
         </p:nvSpPr>
         <p:spPr>
           <a:xfrm>
+            <a:off x="684212" y="269895"/>
+            <a:ext cx="8534400" cy="1507067"/>
+          </a:xfrm>
+        </p:spPr>
+        <p:txBody>
+          <a:bodyPr/>
+          <a:lstStyle/>
+          <a:p>
+            <a:r>
+              <a:rPr lang="pt-PT" dirty="0" err="1"/>
+              <a:t>Triggers</a:t>
+            </a:r>
+            <a:endParaRPr lang="pt-PT" dirty="0"/>
+          </a:p>
+        </p:txBody>
+      </p:sp>
+      <p:sp>
+        <p:nvSpPr>
+          <p:cNvPr id="3" name="Marcador de Posição de Conteúdo 2">
+            <a:extLst>
+              <a:ext uri="{FF2B5EF4-FFF2-40B4-BE49-F238E27FC236}">
+                <a16:creationId xmlns:a16="http://schemas.microsoft.com/office/drawing/2014/main" id="{D1EE8EB0-0B90-4B9B-3BA6-116D5AB53B2E}"/>
+              </a:ext>
+            </a:extLst>
+          </p:cNvPr>
+          <p:cNvSpPr>
+            <a:spLocks noGrp="1"/>
+          </p:cNvSpPr>
+          <p:nvPr>
+            <p:ph idx="1"/>
+          </p:nvPr>
+        </p:nvSpPr>
+        <p:spPr>
+          <a:xfrm>
+            <a:off x="684212" y="1390261"/>
+            <a:ext cx="8982302" cy="2332654"/>
+          </a:xfrm>
+        </p:spPr>
+        <p:txBody>
+          <a:bodyPr>
+            <a:normAutofit/>
+          </a:bodyPr>
+          <a:lstStyle/>
+          <a:p>
+            <a:r>
+              <a:rPr lang="pt-PT" dirty="0" err="1">
+                <a:solidFill>
+                  <a:schemeClr val="bg1"/>
+                </a:solidFill>
+              </a:rPr>
+              <a:t>TriggerCritica</a:t>
+            </a:r>
+            <a:r>
+              <a:rPr lang="pt-PT" dirty="0">
+                <a:solidFill>
+                  <a:schemeClr val="bg1"/>
+                </a:solidFill>
+              </a:rPr>
+              <a:t> – ao inserir uma critica, a pontuação desta critica irá afetar a classificação global do filme</a:t>
+            </a:r>
+          </a:p>
+          <a:p>
+            <a:endParaRPr lang="pt-PT" dirty="0">
+              <a:solidFill>
+                <a:schemeClr val="bg1"/>
+              </a:solidFill>
+            </a:endParaRPr>
+          </a:p>
+        </p:txBody>
+      </p:sp>
+    </p:spTree>
+    <p:extLst>
+      <p:ext uri="{BB962C8B-B14F-4D97-AF65-F5344CB8AC3E}">
+        <p14:creationId xmlns:p14="http://schemas.microsoft.com/office/powerpoint/2010/main" val="3219070465"/>
+      </p:ext>
+    </p:extLst>
+  </p:cSld>
+  <p:clrMapOvr>
+    <a:masterClrMapping/>
+  </p:clrMapOvr>
+</p:sld>
+</file>
+
+<file path=ppt/slides/slide11.xml><?xml version="1.0" encoding="utf-8"?>
+<p:sld xmlns:a="http://schemas.openxmlformats.org/drawingml/2006/main" xmlns:r="http://schemas.openxmlformats.org/officeDocument/2006/relationships" xmlns:p="http://schemas.openxmlformats.org/presentationml/2006/main">
+  <p:cSld>
+    <p:spTree>
+      <p:nvGrpSpPr>
+        <p:cNvPr id="1" name=""/>
+        <p:cNvGrpSpPr/>
+        <p:nvPr/>
+      </p:nvGrpSpPr>
+      <p:grpSpPr>
+        <a:xfrm>
+          <a:off x="0" y="0"/>
+          <a:ext cx="0" cy="0"/>
+          <a:chOff x="0" y="0"/>
+          <a:chExt cx="0" cy="0"/>
+        </a:xfrm>
+      </p:grpSpPr>
+      <p:sp>
+        <p:nvSpPr>
+          <p:cNvPr id="2" name="Título 1">
+            <a:extLst>
+              <a:ext uri="{FF2B5EF4-FFF2-40B4-BE49-F238E27FC236}">
+                <a16:creationId xmlns:a16="http://schemas.microsoft.com/office/drawing/2014/main" id="{3C5CB96C-50CD-E97C-46FE-522F03E82D55}"/>
+              </a:ext>
+            </a:extLst>
+          </p:cNvPr>
+          <p:cNvSpPr>
+            <a:spLocks noGrp="1"/>
+          </p:cNvSpPr>
+          <p:nvPr>
+            <p:ph type="title"/>
+          </p:nvPr>
+        </p:nvSpPr>
+        <p:spPr>
+          <a:xfrm>
             <a:off x="0" y="-9331"/>
             <a:ext cx="12192000" cy="1507067"/>
           </a:xfrm>
@@ -7243,7 +7362,23 @@
           <a:p>
             <a:r>
               <a:rPr lang="pt-PT" dirty="0" err="1"/>
-              <a:t>Triggers</a:t>
+              <a:t>User</a:t>
+            </a:r>
+            <a:r>
+              <a:rPr lang="pt-PT" dirty="0"/>
+              <a:t> </a:t>
+            </a:r>
+            <a:r>
+              <a:rPr lang="pt-PT" dirty="0" err="1"/>
+              <a:t>Defined</a:t>
+            </a:r>
+            <a:r>
+              <a:rPr lang="pt-PT" dirty="0"/>
+              <a:t> </a:t>
+            </a:r>
+            <a:r>
+              <a:rPr lang="pt-PT" dirty="0" err="1"/>
+              <a:t>Functions</a:t>
             </a:r>
             <a:endParaRPr lang="pt-PT" dirty="0"/>
           </a:p>
@@ -7267,8 +7402,8 @@
         </p:nvSpPr>
         <p:spPr>
           <a:xfrm>
-            <a:off x="684212" y="1390261"/>
-            <a:ext cx="8982302" cy="2332654"/>
+            <a:off x="684212" y="1240970"/>
+            <a:ext cx="8982302" cy="5347135"/>
           </a:xfrm>
         </p:spPr>
         <p:txBody>
@@ -7283,7 +7418,7 @@
                   <a:schemeClr val="bg1"/>
                 </a:solidFill>
               </a:rPr>
-              <a:t>TriggerCritica</a:t>
+              <a:t>ShowInfoTeamByMembroId</a:t>
             </a:r>
             <a:r>
               <a:rPr lang="pt-PT" dirty="0">
@@ -7291,7 +7426,7 @@
                   <a:schemeClr val="bg1"/>
                 </a:solidFill>
               </a:rPr>
-              <a:t> – ao inserir uma critica, a pontuação desta critica irá afetar a classificação global do filme</a:t>
+              <a:t> - Devolve todas as informações sobre o membro da equipa respetivo</a:t>
             </a:r>
           </a:p>
           <a:p>
@@ -7301,12 +7436,40 @@
               </a:solidFill>
             </a:endParaRPr>
           </a:p>
+          <a:p>
+            <a:r>
+              <a:rPr lang="pt-PT" dirty="0" err="1">
+                <a:solidFill>
+                  <a:schemeClr val="bg1"/>
+                </a:solidFill>
+              </a:rPr>
+              <a:t>ShowWhereCastByMemberId</a:t>
+            </a:r>
+            <a:r>
+              <a:rPr lang="pt-PT" dirty="0">
+                <a:solidFill>
+                  <a:schemeClr val="bg1"/>
+                </a:solidFill>
+              </a:rPr>
+              <a:t> - Devolve todas os filmes/series onde o membro da equipa já participou</a:t>
+            </a:r>
+          </a:p>
+          <a:p>
+            <a:pPr marL="0" indent="0">
+              <a:buNone/>
+            </a:pPr>
+            <a:endParaRPr lang="pt-PT" dirty="0">
+              <a:solidFill>
+                <a:schemeClr val="bg1"/>
+              </a:solidFill>
+            </a:endParaRPr>
+          </a:p>
         </p:txBody>
       </p:sp>
     </p:spTree>
     <p:extLst>
       <p:ext uri="{BB962C8B-B14F-4D97-AF65-F5344CB8AC3E}">
-        <p14:creationId xmlns:p14="http://schemas.microsoft.com/office/powerpoint/2010/main" val="3219070465"/>
+        <p14:creationId xmlns:p14="http://schemas.microsoft.com/office/powerpoint/2010/main" val="3287226446"/>
       </p:ext>
     </p:extLst>
   </p:cSld>

</xml_diff>